<commit_message>
docs(business): deck v2 - factual corrections from Nitin
(1) Sentientia is NOT live: user data = test import of the prod backup;
all "live in production / serving 3,500+" claims reframed to "proven on
a production data copy, go-live after UAT rehearsal". (2) Tenants named
correctly: airpay internal / public / ZEEA Mafunzo (Tanzania).
(3) Security + AI budget rows -> Pending approval, spend plans to follow
(08-04 memo was a recommendation, not company approval). (4) AI cap to
be estimated; self-hosted local-model (Ollama) option under evaluation.

Co-Authored-By: Claude Fable 5 <noreply@anthropic.com>
</commit_message>
<xml_diff>
--- a/moodle-enhancement/docs/business/SENTIENTIA-EXECUTIVE-DECK-2026-08-21.pptx
+++ b/moodle-enhancement/docs/business/SENTIENTIA-EXECUTIVE-DECK-2026-08-21.pptx
@@ -1137,7 +1137,7 @@
           <a:p>
             <a:r>
               <a:rPr lang="en-US" dirty="0"/>
-              <a:t>Fill the three [to confirm] amounts before presenting: DevOps infra estimate, headcount plan, marketing estimate. The security envelope and AI-cap principle are already signed - anchor on that momentum.</a:t>
+              <a:t>Fill the infra, headcount and marketing amounts before presenting. Security programme + AI budget are PENDING approval - promise the detailed spend-plan annexes. AI cap: being estimated; a self-hosted local-model option (e.g. Ollama on our own server) is under evaluation to shrink it.</a:t>
             </a:r>
             <a:endParaRPr lang="en-US" dirty="0"/>
           </a:p>
@@ -1313,7 +1313,7 @@
           <a:p>
             <a:r>
               <a:rPr lang="en-US" dirty="0"/>
-              <a:t>Item 6 is a "note", not an approval - it protects everyone from date pressure on the production cutover.</a:t>
+              <a:t>Items 1-2 ask for direction, not final numbers - the detailed spend plans follow as annexes. Item 6 is a note, not an approval: it protects everyone from date pressure on the cutover.</a:t>
             </a:r>
             <a:endParaRPr lang="en-US" dirty="0"/>
           </a:p>
@@ -1489,7 +1489,7 @@
           <a:p>
             <a:r>
               <a:rPr lang="en-US" dirty="0"/>
-              <a:t>Key message: this is not a request to start something - the build is largely done and de-risked. The asks fund validation, compliance evidence, and the first sale.</a:t>
+              <a:t>Key message: the build is largely done and de-risked, but be precise - Sentientia is NOT live yet. All user data on it is a copy of the production database used for testing. The asks fund validation, compliance evidence, and the first sale.</a:t>
             </a:r>
             <a:endParaRPr lang="en-US" dirty="0"/>
           </a:p>
@@ -1841,7 +1841,7 @@
           <a:p>
             <a:r>
               <a:rPr lang="en-US" dirty="0"/>
-              <a:t>Everything on this slide is what employees see today on airpay.academy - zero of it existed in the purchased product.</a:t>
+              <a:t>Everything here is built and demonstrated end-to-end on a complete copy of the production database (2,871 employees, 3 tenants incl. ZEEA Mafunzo). Zero of it existed in the purchased product. No live users are on Sentientia yet - go-live follows the UAT rehearsal.</a:t>
             </a:r>
             <a:endParaRPr lang="en-US" dirty="0"/>
           </a:p>
@@ -4120,7 +4120,7 @@
                 <a:ea typeface="Arial" pitchFamily="34" charset="-122"/>
                 <a:cs typeface="Arial" pitchFamily="34" charset="-120"/>
               </a:rPr>
-              <a:t>Every new feature is behind a switch, OFF by default; flipped per customer/tenant only after validation. Production has never broken during this programme.</a:t>
+              <a:t>Every new feature is behind a switch, OFF by default; flipped per customer/tenant only after validation. The current airpay.academy production has stayed untouched throughout - by design.</a:t>
             </a:r>
             <a:endParaRPr lang="en-US" sz="1050" dirty="0"/>
           </a:p>
@@ -5645,7 +5645,7 @@
                 <a:ea typeface="Arial" pitchFamily="34" charset="-122"/>
                 <a:cs typeface="Arial" pitchFamily="34" charset="-120"/>
               </a:rPr>
-              <a:t>Full rehearsal with a copy of live data - the gate before any production cutover</a:t>
+              <a:t>Full rehearsal with a copy of live data - the gate before real users first load onto Sentientia</a:t>
             </a:r>
             <a:endParaRPr lang="en-US" sz="1100" dirty="0"/>
           </a:p>
@@ -9012,7 +9012,7 @@
                 <a:ea typeface="Arial" pitchFamily="34" charset="-122"/>
                 <a:cs typeface="Arial" pitchFamily="34" charset="-120"/>
               </a:rPr>
-              <a:t>Rs 80-120 lakh envelope; exact figure to confirm today</a:t>
+              <a:t>Rs 80-120 lakh envelope (detailed spend plan to follow)</a:t>
             </a:r>
             <a:endParaRPr lang="en-US" sz="1050" dirty="0"/>
           </a:p>
@@ -9045,13 +9045,13 @@
             <a:r>
               <a:rPr lang="en-US" sz="1050" dirty="0">
                 <a:solidFill>
-                  <a:srgbClr val="0066A7"/>
-                </a:solidFill>
-                <a:latin typeface="Arial" pitchFamily="34" charset="0"/>
-                <a:ea typeface="Arial" pitchFamily="34" charset="-122"/>
-                <a:cs typeface="Arial" pitchFamily="34" charset="-120"/>
-              </a:rPr>
-              <a:t>Approved in principle</a:t>
+                  <a:srgbClr val="D97706"/>
+                </a:solidFill>
+                <a:latin typeface="Arial" pitchFamily="34" charset="0"/>
+                <a:ea typeface="Arial" pitchFamily="34" charset="-122"/>
+                <a:cs typeface="Arial" pitchFamily="34" charset="-120"/>
+              </a:rPr>
+              <a:t>Pending approval</a:t>
             </a:r>
             <a:endParaRPr lang="en-US" sz="1050" dirty="0"/>
           </a:p>
@@ -9193,7 +9193,7 @@
                 <a:ea typeface="Arial" pitchFamily="34" charset="-122"/>
                 <a:cs typeface="Arial" pitchFamily="34" charset="-120"/>
               </a:rPr>
-              <a:t>Monthly cap: [to confirm today]</a:t>
+              <a:t>Cap being estimated; self-hosted model option under evaluation</a:t>
             </a:r>
             <a:endParaRPr lang="en-US" sz="1050" dirty="0"/>
           </a:p>
@@ -9226,13 +9226,13 @@
             <a:r>
               <a:rPr lang="en-US" sz="1050" dirty="0">
                 <a:solidFill>
-                  <a:srgbClr val="0066A7"/>
-                </a:solidFill>
-                <a:latin typeface="Arial" pitchFamily="34" charset="0"/>
-                <a:ea typeface="Arial" pitchFamily="34" charset="-122"/>
-                <a:cs typeface="Arial" pitchFamily="34" charset="-120"/>
-              </a:rPr>
-              <a:t>Approved in principle</a:t>
+                  <a:srgbClr val="D97706"/>
+                </a:solidFill>
+                <a:latin typeface="Arial" pitchFamily="34" charset="0"/>
+                <a:ea typeface="Arial" pitchFamily="34" charset="-122"/>
+                <a:cs typeface="Arial" pitchFamily="34" charset="-120"/>
+              </a:rPr>
+              <a:t>Pending approval</a:t>
             </a:r>
             <a:endParaRPr lang="en-US" sz="1050" dirty="0"/>
           </a:p>
@@ -9814,7 +9814,7 @@
                 <a:ea typeface="Arial" pitchFamily="34" charset="-122"/>
                 <a:cs typeface="Arial" pitchFamily="34" charset="-120"/>
               </a:rPr>
-              <a:t>The two "approved in principle" lines were signed in the August decision memo - today we ask for the numbers, so vendors can be committed.</a:t>
+              <a:t>Detailed line-item spend plans for the security programme and the AI budget will be circulated before sign-off - approval on direction is requested today.</a:t>
             </a:r>
             <a:endParaRPr lang="en-US" sz="1150" dirty="0"/>
           </a:p>
@@ -10240,7 +10240,7 @@
                 <a:ea typeface="Arial" pitchFamily="34" charset="-122"/>
                 <a:cs typeface="Arial" pitchFamily="34" charset="-120"/>
               </a:rPr>
-              <a:t>airpay is the only production customer today.  </a:t>
+              <a:t>airpay is the only customer, and Sentientia is not live yet.  </a:t>
             </a:r>
             <a:pPr indent="0" marL="0">
               <a:buNone/>
@@ -10254,7 +10254,7 @@
                 <a:ea typeface="Arial" pitchFamily="34" charset="-122"/>
                 <a:cs typeface="Arial" pitchFamily="34" charset="-120"/>
               </a:rPr>
-              <a:t>Multi-customer architecture already demonstrated; demo customer + first external pilot are explicit roadmap items with dates.</a:t>
+              <a:t>UAT validation + migration rehearsal are the immediate path to go-live; multi-customer architecture demonstrated; first external pilot is a dated roadmap item.</a:t>
             </a:r>
             <a:endParaRPr lang="en-US" sz="980" dirty="0"/>
           </a:p>
@@ -11071,7 +11071,7 @@
                 <a:ea typeface="Arial" pitchFamily="34" charset="-122"/>
                 <a:cs typeface="Arial" pitchFamily="34" charset="-120"/>
               </a:rPr>
-              <a:t>Confirm the security &amp; certification figure within the approved Rs 80-120 lakh envelope</a:t>
+              <a:t>Approve the security &amp; certification programme direction (Rs 80-120 lakh envelope; spend plan to follow)</a:t>
             </a:r>
             <a:endParaRPr lang="en-US" sz="1300" dirty="0"/>
           </a:p>
@@ -11196,7 +11196,7 @@
                 <a:ea typeface="Arial" pitchFamily="34" charset="-122"/>
                 <a:cs typeface="Arial" pitchFamily="34" charset="-120"/>
               </a:rPr>
-              <a:t>Approve the AI monthly operating cap and authorise the API key provisioning</a:t>
+              <a:t>Approve the AI budget direction - cap to be estimated, incl. evaluating self-hosted models to cut cost</a:t>
             </a:r>
             <a:endParaRPr lang="en-US" sz="1300" dirty="0"/>
           </a:p>
@@ -11926,7 +11926,7 @@
                 <a:ea typeface="Arial" pitchFamily="34" charset="-122"/>
                 <a:cs typeface="Arial" pitchFamily="34" charset="-120"/>
               </a:rPr>
-              <a:t>LIVE IN PRODUCTION</a:t>
+              <a:t>CORE PLATFORM (on by default at go-live)</a:t>
             </a:r>
             <a:endParaRPr lang="en-US" sz="1000" dirty="0"/>
           </a:p>
@@ -12261,7 +12261,7 @@
                 <a:ea typeface="Arial" pitchFamily="34" charset="-122"/>
                 <a:cs typeface="Arial" pitchFamily="34" charset="-120"/>
               </a:rPr>
-              <a:t>BUILT - STAGED BEHIND SWITCHES (UAT PHASE)</a:t>
+              <a:t>ADVANCED - FEATURE-FLAGGED (validated on UAT first)</a:t>
             </a:r>
             <a:endParaRPr lang="en-US" sz="1000" dirty="0"/>
           </a:p>
@@ -12775,7 +12775,7 @@
                 <a:ea typeface="Arial" pitchFamily="34" charset="-122"/>
                 <a:cs typeface="Arial" pitchFamily="34" charset="-120"/>
               </a:rPr>
-              <a:t>The learning platform we purchased (and pay AMC on) has been rebuilt in-house into Sentientia LMS: a fully owned, white-label, AI-ready enterprise platform. Employees already use the new experience foundation in production; the advanced feature set is built, tested and staged behind switches, entering formal validation on the newly provisioned UAT environment this month.</a:t>
+              <a:t>The learning platform we purchased (and pay AMC on) has been rebuilt in-house into Sentientia LMS: a fully owned, white-label, AI-ready enterprise platform. The platform is feature-complete and hardened against a full copy of production data (all 3 tenants); it is not yet serving live users. Formal validation begins on the newly provisioned UAT environment this month; real users load only after a passed migration rehearsal.</a:t>
             </a:r>
             <a:endParaRPr lang="en-US" sz="1300" dirty="0"/>
           </a:p>
@@ -13009,7 +13009,7 @@
                 <a:ea typeface="Arial" pitchFamily="34" charset="-122"/>
                 <a:cs typeface="Arial" pitchFamily="34" charset="-120"/>
               </a:rPr>
-              <a:t>employees on the platform across 3 business units</a:t>
+              <a:t>real user records in the production data copy it is hardened against (3 tenants)</a:t>
             </a:r>
             <a:endParaRPr lang="en-US" sz="1050" dirty="0"/>
           </a:p>
@@ -13202,7 +13202,7 @@
                 <a:ea typeface="Arial" pitchFamily="34" charset="-122"/>
                 <a:cs typeface="Arial" pitchFamily="34" charset="-120"/>
               </a:rPr>
-              <a:t>1.  Confirm the security &amp; certification budget figure (envelope already approved in principle)</a:t>
+              <a:t>1.  Approve the security &amp; certification programme (Rs 80-120 lakh envelope; detailed spend plan to follow)</a:t>
             </a:r>
             <a:endParaRPr lang="en-US" sz="1350" dirty="0"/>
           </a:p>
@@ -13222,7 +13222,7 @@
                 <a:ea typeface="Arial" pitchFamily="34" charset="-122"/>
                 <a:cs typeface="Arial" pitchFamily="34" charset="-120"/>
               </a:rPr>
-              <a:t>2.  Approve the AI operating budget (monthly cap) so the built AI suite can go live safely</a:t>
+              <a:t>2.  Approve the AI operating budget in principle - monthly cap being estimated, incl. a self-hosted model option to reduce it</a:t>
             </a:r>
             <a:endParaRPr lang="en-US" sz="1350" dirty="0"/>
           </a:p>
@@ -14579,7 +14579,7 @@
                 <a:ea typeface="Arial" pitchFamily="34" charset="-122"/>
                 <a:cs typeface="Arial" pitchFamily="34" charset="-120"/>
               </a:rPr>
-              <a:t>Served core compliance training for 3 business units</a:t>
+              <a:t>Serves compliance training for 3 tenants: airpay internal, public, and ZEEA Mafunzo (Tanzania)</a:t>
             </a:r>
             <a:endParaRPr lang="en-US" sz="1250" dirty="0"/>
           </a:p>
@@ -16114,7 +16114,7 @@
                 <a:ea typeface="Arial" pitchFamily="34" charset="-122"/>
                 <a:cs typeface="Arial" pitchFamily="34" charset="-120"/>
               </a:rPr>
-              <a:t>ALREADY DELIVERED</a:t>
+              <a:t>BUILT &amp; WORKING</a:t>
             </a:r>
             <a:endParaRPr lang="en-US" sz="1200" dirty="0"/>
           </a:p>
@@ -16153,7 +16153,7 @@
                 <a:ea typeface="Arial" pitchFamily="34" charset="-122"/>
                 <a:cs typeface="Arial" pitchFamily="34" charset="-120"/>
               </a:rPr>
-              <a:t>Live in production today - serving 3,500+ employees</a:t>
+              <a:t>The everyday platform, rebuilt - proven on production-scale data</a:t>
             </a:r>
             <a:endParaRPr lang="en-US" sz="3000" dirty="0"/>
           </a:p>
@@ -19829,7 +19829,7 @@
                 <a:ea typeface="Arial" pitchFamily="34" charset="-122"/>
                 <a:cs typeface="Arial" pitchFamily="34" charset="-120"/>
               </a:rPr>
-              <a:t>All feature-flagged and dormant in production until validated - production behaviour never changes by accident.</a:t>
+              <a:t>All feature-flagged and OFF by default until validated - platform behaviour never changes by accident.</a:t>
             </a:r>
             <a:endParaRPr lang="en-US" sz="1200" dirty="0"/>
           </a:p>

</xml_diff>